<commit_message>
docs(v2): report, KT and final-sem deck brought in line with the 24 October fixes (halving, 10 minute limit, heartbeat, technical detail, 76/29/15 tests)
Co-Authored-By: Claude Sonnet 5.5 <noreply@anthropic.com>
</commit_message>
<xml_diff>
--- a/finalsem/docs/ppt/FinalSem_Deck.pptx
+++ b/finalsem/docs/ppt/FinalSem_Deck.pptx
@@ -1225,7 +1225,7 @@
           <a:lstStyle/>
           <a:p>
             <a:r>
-              <a:t>The tests run at three levels. There are 70 unit tests, which check the small rules without a browser or a network. There are 26 browser scenarios, which ran in a hidden Chromium with a pretend model, and they passed in three full runs. The 15 Windows script checks test the batch files and the PowerShell scripts. The four clean real-model run files are the only numbers I quote for speed.</a:t>
+              <a:t>The tests run at three levels. There are 76 unit tests, which check the small rules without a browser or a network. There are 29 browser scenarios, which run in a hidden Chromium with a pretend model, and they all pass. The 15 Windows script checks test the batch files and the PowerShell scripts. The four clean real-model run files are the only numbers I quote for speed.</a:t>
             </a:r>
           </a:p>
         </p:txBody>
@@ -1435,7 +1435,7 @@
           <a:lstStyle/>
           <a:p>
             <a:r>
-              <a:t>I met four real problems on 21 October, and each one is written in the development log. The first was the graphics chip: Chrome picked the weak Intel chip, so the first answers were very slow. The second was the model cache, which failed inside the hidden page until I switched the storage. The third was silent: the small model wrote summaries with no sign on screen. The fourth was a wrong Downloading line on a model that was already stored.</a:t>
+              <a:t>I met four real problems on 21 October, and each one is written in the development log. The first was the graphics chip: Chrome picked the weak Intel chip, so the first answers were very slow. The second was the model cache, which failed inside the hidden page until I switched the storage. The third was silent: the small model wrote summaries with no sign on screen. The fourth was a wrong Downloading line on a model that was already stored. The fifth problem came from the real Chrome on 24 October. On the long Wikipedia page the popup only said that something went wrong inside the extension. I repeated it in a hidden browser and found two weak spots: one answer on the Intel chip took longer than the three-minute limit, and a part that did not fit the model's window was reported as a vague error. Now such a part is cut in half and tried again, the answer limit is ten minutes, and the popup shows a technical detail line.</a:t>
             </a:r>
           </a:p>
         </p:txBody>
@@ -1505,7 +1505,7 @@
           <a:lstStyle/>
           <a:p>
             <a:r>
-              <a:t>Some things are not finished, and I want to be exact about them. The client's laptop has not been tested, so its numbers are not known yet. The setting that moves Chrome to the card was tested only against a throw-away registry key. Every browser test and real run used a hidden Chromium, so I have not clicked through the daily Chrome window. The model is meant for English text, and it makes small slips.</a:t>
+              <a:t>Some things are not finished, and I want to be exact about them. The client's laptop has not been tested, so its numbers are not known yet. The setting that moves Chrome to the card was tested only against a throw-away registry key. Every browser test and real run used a hidden Chromium, so I have not clicked through the daily Chrome window. The model is meant for English text, and it makes small slips. Two more limits. On the Intel chip the seven-part Lighthouse article took 616 seconds, about ten minutes, and the summary was poor. The step that cuts a too-long part in half is covered by unit tests and the pretend model, because no real part overflowed the window on that day.</a:t>
             </a:r>
           </a:p>
         </p:txBody>
@@ -11009,7 +11009,7 @@
                 </a:solidFill>
                 <a:latin typeface="Georgia"/>
               </a:rPr>
-              <a:t>70</a:t>
+              <a:t>76</a:t>
             </a:r>
           </a:p>
         </p:txBody>
@@ -11123,7 +11123,7 @@
                 </a:solidFill>
                 <a:latin typeface="Georgia"/>
               </a:rPr>
-              <a:t>26</a:t>
+              <a:t>29</a:t>
             </a:r>
           </a:p>
         </p:txBody>
@@ -11158,7 +11158,7 @@
                 </a:solidFill>
                 <a:latin typeface="Segoe UI"/>
               </a:rPr>
-              <a:t>browser scenarios, passing in three full runs</a:t>
+              <a:t>browser scenarios, all passing</a:t>
             </a:r>
           </a:p>
         </p:txBody>
@@ -13044,7 +13044,7 @@
         </p:nvGraphicFramePr>
         <p:xfrm>
           <a:off x="685800" y="1600200"/>
-          <a:ext cx="10820094" cy="2834640"/>
+          <a:ext cx="10820094" cy="3401568"/>
         </p:xfrm>
         <a:graphic>
           <a:graphicData uri="http://schemas.openxmlformats.org/drawingml/2006/table">
@@ -13316,6 +13316,58 @@
                   </a:tcPr>
                 </a:tc>
               </a:tr>
+              <a:tr h="566928">
+                <a:tc>
+                  <a:txBody>
+                    <a:bodyPr/>
+                    <a:lstStyle/>
+                    <a:p>
+                      <a:r>
+                        <a:rPr sz="1600" b="0">
+                          <a:solidFill>
+                            <a:srgbClr val="1C1B1A"/>
+                          </a:solidFill>
+                          <a:latin typeface="Segoe UI"/>
+                        </a:rPr>
+                        <a:t>Real Chrome, long Wikipedia page, Intel chip: a vague error with no reason</a:t>
+                      </a:r>
+                    </a:p>
+                  </a:txBody>
+                  <a:tcPr anchor="ctr" marL="91440" marR="91440" marT="27432" marB="27432">
+                    <a:lnB w="9525">
+                      <a:solidFill>
+                        <a:srgbClr val="D9D2C3"/>
+                      </a:solidFill>
+                    </a:lnB>
+                    <a:noFill/>
+                  </a:tcPr>
+                </a:tc>
+                <a:tc>
+                  <a:txBody>
+                    <a:bodyPr/>
+                    <a:lstStyle/>
+                    <a:p>
+                      <a:r>
+                        <a:rPr sz="1600" b="0">
+                          <a:solidFill>
+                            <a:srgbClr val="1C1B1A"/>
+                          </a:solidFill>
+                          <a:latin typeface="Segoe UI"/>
+                        </a:rPr>
+                        <a:t>A part too long for the model is cut in half and retried. The answer limit is 10 minutes. The popup now shows a technical detail line.</a:t>
+                      </a:r>
+                    </a:p>
+                  </a:txBody>
+                  <a:tcPr anchor="ctr" marL="91440" marR="91440" marT="27432" marB="27432">
+                    <a:lnB w="9525">
+                      <a:solidFill>
+                        <a:srgbClr val="D9D2C3"/>
+                      </a:solidFill>
+                    </a:lnB>
+                    <a:noFill/>
+                  </a:tcPr>
+                </a:tc>
+              </a:tr>
             </a:tbl>
           </a:graphicData>
         </a:graphic>
@@ -13328,7 +13380,7 @@
         </p:nvSpPr>
         <p:spPr>
           <a:xfrm>
-            <a:off x="685800" y="4572000"/>
+            <a:off x="685800" y="5138928"/>
             <a:ext cx="10820095" cy="640080"/>
           </a:xfrm>
           <a:prstGeom prst="rect">
@@ -13350,7 +13402,7 @@
                 </a:solidFill>
                 <a:latin typeface="Segoe UI"/>
               </a:rPr>
-              <a:t>Found and fixed on 21 October 2026. Each one is written in the development log.</a:t>
+              <a:t>Found and fixed on 21 and 24 October 2026. Each one is written in the development log.</a:t>
             </a:r>
           </a:p>
         </p:txBody>
@@ -13641,7 +13693,7 @@
                 </a:solidFill>
                 <a:latin typeface="Segoe UI"/>
               </a:rPr>
-              <a:t>Visible Chrome: no click-through yet. All tests used hidden Chromium.</a:t>
+              <a:t>Visible Chrome: one real page on 24 October, no full click-through yet.</a:t>
             </a:r>
           </a:p>
           <a:p>
@@ -13689,7 +13741,7 @@
                 </a:solidFill>
                 <a:latin typeface="Segoe UI"/>
               </a:rPr>
-              <a:t>Small-model slips: repeated prompt wording, and factual errors.</a:t>
+              <a:t>Small-model slips. A 7-part page takes about 10 minutes on the Intel chip.</a:t>
             </a:r>
           </a:p>
           <a:p>
@@ -13713,7 +13765,7 @@
                 </a:solidFill>
                 <a:latin typeface="Segoe UI"/>
               </a:rPr>
-              <a:t>Closing a tab does not stop a download; the small-model choice persists.</a:t>
+              <a:t>Cutting a long part in half is tested with the pretend model only.</a:t>
             </a:r>
           </a:p>
         </p:txBody>

</xml_diff>

<commit_message>
docs(v2): report, KT, README, manual test sheet and final-sem deck updated for the speed work on built-in graphics (client laptop facts, D7, new numbers)
Co-Authored-By: Claude Sonnet 5.5 <noreply@anthropic.com>
</commit_message>
<xml_diff>
--- a/finalsem/docs/ppt/FinalSem_Deck.pptx
+++ b/finalsem/docs/ppt/FinalSem_Deck.pptx
@@ -735,7 +735,7 @@
           <a:lstStyle/>
           <a:p>
             <a:r>
-              <a:t>The extension checks the computer before it starts. Without WebGPU or the 16-bit math feature, it refuses with a plain message instead of failing quietly. On an integrated chip it chooses the smaller model and shows a note. If the main model runs out of graphics memory, the small model tries the job, and the popup says so. That choice is saved, so it stays until the stored settings are cleared.</a:t>
+              <a:t>The extension checks the graphics card before anything else. Without WebGPU or the 16-bit math feature it refuses and says why. On built-in graphics, like the client's laptop, it keeps the accurate main model and instead reads less of a long page. The reader can choose Fast in Settings, which uses the small model, but I measured that its summaries are often wrong. A memory failure also sends the extension to the small model, and that choice stays until the stored settings are cleared.</a:t>
             </a:r>
           </a:p>
         </p:txBody>
@@ -805,7 +805,7 @@
           <a:lstStyle/>
           <a:p>
             <a:r>
-              <a:t>Many laptops have a weak graphics chip built into the processor and a stronger separate card. On this laptop Chrome used the Intel chip by default, so the extension chose the smaller model and showed a note. With the NVIDIA card, the 1B model wrote 34 to 53 tokens a second in the clean runs. The setting that moves Chrome to the card is opt-in, and it has been tested only against a throw-away registry key.</a:t>
+              <a:t>I measured how fast each small model reads and writes on the built-in Intel chip. Reading is the slow part: the chip reads only 15 to 40 tokens a second, whatever the model size, and a normal part of 6,000 characters is about 1,440 tokens. That is why one part takes a minute or more, and why a smaller model does not help much. The separate NVIDIA card reads about 40 times faster. The developer laptop has both chips, but the client's laptop has only the Intel one, so the Intel numbers are the ones that matter for the client. All of these numbers are from a hidden test browser on the developer laptop, not from the client's laptop.</a:t>
             </a:r>
           </a:p>
         </p:txBody>
@@ -875,7 +875,7 @@
           <a:lstStyle/>
           <a:p>
             <a:r>
-              <a:t>Long pages are cut into parts of at most 6,000 characters, which is about 1,500 tokens. Each part gets its own summary, and then one request merges the part summaries. This is the clean run of a Lighthouse article in seven parts. It finished at 74.1 seconds, with the model already stored and loaded.</a:t>
+              <a:t>A long page costs time in proportion to the text the model must read. On the Wikipedia Lighthouse page, a quarter of the text is notes and bibliography, so that is cut first. On built-in graphics the extension then keeps the opening in full and the first sentences of the paragraphs, spread over the page, which is about 6,000 characters or one part. The popup says how much was read, and a button reads the whole page if the person wants it. This took the Lighthouse page from 616 seconds to 125 seconds, and the summary was accurate. The cost is coverage: the summary rests on about a fifth of the text.</a:t>
             </a:r>
           </a:p>
         </p:txBody>
@@ -1155,7 +1155,7 @@
           <a:lstStyle/>
           <a:p>
             <a:r>
-              <a:t>The client uses four scripts. setup.bat checks Chrome and the files, and it ends with SETUP COMPLETE or SETUP FAILED. run.bat opens the extensions page, and the client clicks Load unpacked by hand. check-computer.ps1 reports the laptop's memory, graphics chips and free space. The setup.bat --gpu option changes a Windows setting, so it runs only when the client asks for it.</a:t>
+              <a:t>The client uses four scripts. setup.bat checks Chrome and the files, and it ends with SETUP COMPLETE or SETUP FAILED. run.bat opens the extensions page, and the client clicks Load unpacked by hand. check-computer.ps1 reports the laptop's memory, graphics chips and free space. The setup.bat --gpu option changes a Windows setting, so it runs only when the client asks for it. The client's laptop has one graphics chip, so the graphics switch is not needed there. The first use downloads about 695 megabytes.</a:t>
             </a:r>
           </a:p>
         </p:txBody>
@@ -1225,7 +1225,7 @@
           <a:lstStyle/>
           <a:p>
             <a:r>
-              <a:t>The tests run at three levels. There are 76 unit tests, which check the small rules without a browser or a network. There are 29 browser scenarios, which run in a hidden Chromium with a pretend model, and they all pass. The 15 Windows script checks test the batch files and the PowerShell scripts. The four clean real-model run files are the only numbers I quote for speed.</a:t>
+              <a:t>The tests run at three levels. There are 93 unit tests, which check the small rules without a browser or a network. There are 31 browser scenarios, which run in a hidden Chromium with a pretend model, and they all pass. The 15 Windows script checks test the batch files and the PowerShell scripts. The four clean real-model run files are the only numbers I quote for speed.</a:t>
             </a:r>
           </a:p>
         </p:txBody>
@@ -1365,7 +1365,7 @@
           <a:lstStyle/>
           <a:p>
             <a:r>
-              <a:t>These are the clean runs only. Each run file says at the top whether other programs were running, and these runs have no such note. The after-label-fix runs show 65 and 45 tokens a second, which is above the 34 to 53 range of the earlier clean runs, so I show both. The Intel run file has no such note, so I treat it as clean. Runs made while other programs were running are left out, because they are slower for a reason that has nothing to do with the code.</a:t>
+              <a:t>These are the clean runs. The first three rows are the NVIDIA card. The fourth row is the old Intel result, before the speed work: ten minutes for the Lighthouse page. The next three rows are the Intel chip with the new defaults: the accurate main model, long pages shortened, and short answers. The Lighthouse page now takes about two minutes. The last row is the Fast setting. It is quicker, but its Lighthouse summary only repeated the prompt, which is why Fast is not the default. None of these numbers comes from the client's laptop. I expect about two minutes there, and I will measure it.</a:t>
             </a:r>
           </a:p>
         </p:txBody>
@@ -1435,7 +1435,7 @@
           <a:lstStyle/>
           <a:p>
             <a:r>
-              <a:t>I met four real problems on 21 October, and each one is written in the development log. The first was the graphics chip: Chrome picked the weak Intel chip, so the first answers were very slow. The second was the model cache, which failed inside the hidden page until I switched the storage. The third was silent: the small model wrote summaries with no sign on screen. The fourth was a wrong Downloading line on a model that was already stored. The fifth problem came from the real Chrome on 24 October. On the long Wikipedia page the popup only said that something went wrong inside the extension. I repeated it in a hidden browser and found two weak spots: one answer on the Intel chip took longer than the three-minute limit, and a part that did not fit the model's window was reported as a vague error. Now such a part is cut in half and tried again, the answer limit is ten minutes, and the popup shows a technical detail line.</a:t>
+              <a:t>I met four real problems on 21 October, and each one is written in the development log. The first was the graphics chip: Chrome picked the weak Intel chip, so the first answers were very slow. The second was the model cache, which failed inside the hidden page until I switched the storage. The third was silent: the small model wrote summaries with no sign on screen. The fourth was a wrong Downloading line on a model that was already stored. The fifth problem came from the real Chrome on 24 October. On the long Wikipedia page the popup only said that something went wrong inside the extension. I repeated it in a hidden browser and found two weak spots: one answer on the Intel chip took longer than the three-minute limit, and a part that did not fit the model's window was reported as a vague error. Now such a part is cut in half and tried again, the answer limit is ten minutes, and the popup shows a technical detail line. The sixth problem came from the client's laptop details. It has only built-in graphics, and a long page took about ten minutes there. I measured where the time went and found it was reading, not writing. I asked a stronger model for advice, and then built the shorter reading. The Lighthouse page went from 616 seconds to 125 seconds.</a:t>
             </a:r>
           </a:p>
         </p:txBody>
@@ -1505,7 +1505,7 @@
           <a:lstStyle/>
           <a:p>
             <a:r>
-              <a:t>Some things are not finished, and I want to be exact about them. The client's laptop has not been tested, so its numbers are not known yet. The setting that moves Chrome to the card was tested only against a throw-away registry key. Every browser test and real run used a hidden Chromium, so I have not clicked through the daily Chrome window. The model is meant for English text, and it makes small slips. Two more limits. On the Intel chip the seven-part Lighthouse article took 616 seconds, about ten minutes, and the summary was poor. The step that cuts a too-long part in half is covered by unit tests and the pretend model, because no real part overflowed the window on that day.</a:t>
+              <a:t>Some things are not finished, and I want to be exact about them. The client's laptop details are known, but I have not run the extension on it, so its real speed is not measured. All my speed numbers come from a hidden test browser on the developer laptop, and a visible window might be faster or slower. A shortened summary rests on about a fifth of a long page, and reading the whole page takes five to twelve minutes on this kind of chip. The model is small and made for English. I did not try a different engine, because a stronger model advised me to measure in a visible window first. Cutting a too-long part in half is covered by unit tests and the pretend model, because no real part overflowed the window.</a:t>
             </a:r>
           </a:p>
         </p:txBody>
@@ -1785,7 +1785,7 @@
           <a:lstStyle/>
           <a:p>
             <a:r>
-              <a:t>This table shows what changed between the two versions. Version 1 needed a Google key and sent each part of the page to Google. Version 2 downloads the model once, and then works without a key and without the internet. The speed row gives the measured times for this laptop, and I say which run each one comes from.</a:t>
+              <a:t>This table sets Version 2 next to Version 1. The model now lives on the laptop, so there is no key and no cloud. The page text stays on the laptop, and the only internet use is the one-time download of about 695 megabytes. Speed depends on the graphics chip. The client's laptop has only built-in Intel graphics, so I measured that case: a long Wikipedia page takes about two minutes. I did not measure summary quality in either version with a score, so I only say what I saw in the saved summaries.</a:t>
             </a:r>
           </a:p>
         </p:txBody>
@@ -7342,7 +7342,7 @@
                           </a:solidFill>
                           <a:latin typeface="Segoe UI"/>
                         </a:rPr>
-                        <a:t>Integrated (Intel) graphics</a:t>
+                        <a:t>Built-in (Intel) graphics, like the client's</a:t>
                       </a:r>
                     </a:p>
                   </a:txBody>
@@ -7367,7 +7367,7 @@
                           </a:solidFill>
                           <a:latin typeface="Segoe UI"/>
                         </a:rPr>
-                        <a:t>Picks SmolLM2 360M by itself and shows a note: answers can be slow.</a:t>
+                        <a:t>Keeps the main model, shows a note that answers can be slow, and reads at most 6,000 characters of a long page.</a:t>
                       </a:r>
                     </a:p>
                   </a:txBody>
@@ -7394,7 +7394,7 @@
                           </a:solidFill>
                           <a:latin typeface="Segoe UI"/>
                         </a:rPr>
-                        <a:t>Under 8 GB of memory (rule)</a:t>
+                        <a:t>Settings, Quality: Fast</a:t>
                       </a:r>
                     </a:p>
                   </a:txBody>
@@ -7419,7 +7419,7 @@
                           </a:solidFill>
                           <a:latin typeface="Segoe UI"/>
                         </a:rPr>
-                        <a:t>Picks SmolLM2 360M. The rule has not been seen on real low-memory hardware.</a:t>
+                        <a:t>Uses SmolLM2 360M: about 2 times quicker, but summaries are often muddled or wrong.</a:t>
                       </a:r>
                     </a:p>
                   </a:txBody>
@@ -7446,7 +7446,7 @@
                           </a:solidFill>
                           <a:latin typeface="Segoe UI"/>
                         </a:rPr>
-                        <a:t>Main model runs out of graphics memory</a:t>
+                        <a:t>Under 8 GB of memory (rule)</a:t>
                       </a:r>
                     </a:p>
                   </a:txBody>
@@ -7471,7 +7471,7 @@
                           </a:solidFill>
                           <a:latin typeface="Segoe UI"/>
                         </a:rPr>
-                        <a:t>Tries SmolLM2 360M once. The summary carries a notice that it may be less detailed.</a:t>
+                        <a:t>Picks SmolLM2 360M. The rule has not been seen on real low-memory hardware.</a:t>
                       </a:r>
                     </a:p>
                   </a:txBody>
@@ -7498,7 +7498,7 @@
                           </a:solidFill>
                           <a:latin typeface="Segoe UI"/>
                         </a:rPr>
-                        <a:t>A fallback choice is made</a:t>
+                        <a:t>Main model runs out of graphics memory</a:t>
                       </a:r>
                     </a:p>
                   </a:txBody>
@@ -7523,7 +7523,7 @@
                           </a:solidFill>
                           <a:latin typeface="Segoe UI"/>
                         </a:rPr>
-                        <a:t>It stays on SmolLM2 360M until the stored settings are cleared.</a:t>
+                        <a:t>Tries SmolLM2 360M once. The summary carries a notice that it may be less detailed, and the choice is kept.</a:t>
                       </a:r>
                     </a:p>
                   </a:txBody>
@@ -7571,7 +7571,7 @@
                 </a:solidFill>
                 <a:latin typeface="Segoe UI"/>
               </a:rPr>
-              <a:t>The extension makes these choices, not the reader. The main model is about 695 MB; SmolLM2 360M is about 204 MB.</a:t>
+              <a:t>The extension makes these choices, except Quality, which the reader sets. The main model is about 695 MB; SmolLM2 360M is about 204 MB.</a:t>
             </a:r>
           </a:p>
         </p:txBody>
@@ -7632,7 +7632,7 @@
                 </a:solidFill>
                 <a:latin typeface="Georgia"/>
               </a:rPr>
-              <a:t>Two graphics chips: the default is slow</a:t>
+              <a:t>Built-in graphics: reading is the slow part</a:t>
             </a:r>
           </a:p>
         </p:txBody>
@@ -7870,7 +7870,7 @@
                 </a:solidFill>
                 <a:latin typeface="Segoe UI"/>
               </a:rPr>
-              <a:t>SmolLM2 360M: 4 to 5 tokens a second in a saved clean run.</a:t>
+              <a:t>Llama 3.2 1B: reads 15.6 and writes 2 tokens a second.</a:t>
             </a:r>
           </a:p>
           <a:p>
@@ -7894,7 +7894,7 @@
                 </a:solidFill>
                 <a:latin typeface="Segoe UI"/>
               </a:rPr>
-              <a:t>The 1B model wrote about 2 tokens a second in a speed test.</a:t>
+              <a:t>SmolLM2 360M: reads 26 to 29 and writes 4.7.</a:t>
             </a:r>
           </a:p>
           <a:p>
@@ -7918,7 +7918,7 @@
                 </a:solidFill>
                 <a:latin typeface="Segoe UI"/>
               </a:rPr>
-              <a:t>Short article, first use: 199.2 s, including an 81 s download.</a:t>
+              <a:t>Reading is about 80% of the time of one part.</a:t>
             </a:r>
           </a:p>
           <a:p>
@@ -7942,7 +7942,7 @@
                 </a:solidFill>
                 <a:latin typeface="Segoe UI"/>
               </a:rPr>
-              <a:t>Chrome used this chip by default on this laptop.</a:t>
+              <a:t>The client's laptop has this kind of chip (Iris Xe).</a:t>
             </a:r>
           </a:p>
         </p:txBody>
@@ -8045,7 +8045,7 @@
                 </a:solidFill>
                 <a:latin typeface="Segoe UI"/>
               </a:rPr>
-              <a:t>Llama 3.2 1B: 34 to 53 tokens a second in clean runs.</a:t>
+              <a:t>Llama 3.2 1B: writes 34 to 53 tokens a second in clean runs.</a:t>
             </a:r>
           </a:p>
           <a:p>
@@ -8069,7 +8069,7 @@
                 </a:solidFill>
                 <a:latin typeface="Segoe UI"/>
               </a:rPr>
-              <a:t>Short article, model stored: 15.3 s before the label fix, 17.7 s after it.</a:t>
+              <a:t>Reads about 600 tokens a second (speed test, not a saved run).</a:t>
             </a:r>
           </a:p>
           <a:p>
@@ -8093,7 +8093,7 @@
                 </a:solidFill>
                 <a:latin typeface="Segoe UI"/>
               </a:rPr>
-              <a:t>The Windows Graphics setting or setup.bat --gpu (opt-in) moves Chrome to it.</a:t>
+              <a:t>Short article, model stored: 15.3 s before the label fix, 17.7 s after.</a:t>
             </a:r>
           </a:p>
           <a:p>
@@ -8117,7 +8117,7 @@
                 </a:solidFill>
                 <a:latin typeface="Segoe UI"/>
               </a:rPr>
-              <a:t>setup.bat --gpu was tested only against a throw-away registry key.</a:t>
+              <a:t>The developer laptop has both chips; the client's has only the Intel one.</a:t>
             </a:r>
           </a:p>
         </p:txBody>
@@ -8178,7 +8178,7 @@
                 </a:solidFill>
                 <a:latin typeface="Georgia"/>
               </a:rPr>
-              <a:t>Long pages are cut into parts</a:t>
+              <a:t>Long pages: read less on slow chips</a:t>
             </a:r>
           </a:p>
         </p:txBody>
@@ -8328,7 +8328,7 @@
         </p:nvGraphicFramePr>
         <p:xfrm>
           <a:off x="685800" y="1600200"/>
-          <a:ext cx="10820094" cy="4069080"/>
+          <a:ext cx="10820094" cy="3968496"/>
         </p:xfrm>
         <a:graphic>
           <a:graphicData uri="http://schemas.openxmlformats.org/drawingml/2006/table">
@@ -8337,10 +8337,10 @@
                 <a:tableStyleId>{2D5ABB26-0587-4C30-8999-92F81FD0307C}</a:tableStyleId>
               </a:tblPr>
               <a:tblGrid>
-                <a:gridCol w="8802789"/>
-                <a:gridCol w="2017305"/>
+                <a:gridCol w="6968874"/>
+                <a:gridCol w="3851220"/>
               </a:tblGrid>
-              <a:tr h="452120">
+              <a:tr h="566928">
                 <a:tc>
                   <a:txBody>
                     <a:bodyPr/>
@@ -8353,7 +8353,7 @@
                           </a:solidFill>
                           <a:latin typeface="Segoe UI"/>
                         </a:rPr>
-                        <a:t>Popup line, Lighthouse article (clean run)</a:t>
+                        <a:t>Wikipedia Lighthouse page, built-in Intel graphics</a:t>
                       </a:r>
                     </a:p>
                   </a:txBody>
@@ -8378,7 +8378,7 @@
                           </a:solidFill>
                           <a:latin typeface="Segoe UI"/>
                         </a:rPr>
-                        <a:t>At (s)</a:t>
+                        <a:t>Value</a:t>
                       </a:r>
                     </a:p>
                   </a:txBody>
@@ -8392,7 +8392,7 @@
                   </a:tcPr>
                 </a:tc>
               </a:tr>
-              <a:tr h="452120">
+              <a:tr h="566928">
                 <a:tc>
                   <a:txBody>
                     <a:bodyPr/>
@@ -8405,7 +8405,7 @@
                           </a:solidFill>
                           <a:latin typeface="Segoe UI"/>
                         </a:rPr>
-                        <a:t>Summarizing part 1 of 7...</a:t>
+                        <a:t>Text the extension reads from the page</a:t>
                       </a:r>
                     </a:p>
                   </a:txBody>
@@ -8430,7 +8430,7 @@
                           </a:solidFill>
                           <a:latin typeface="Segoe UI"/>
                         </a:rPr>
-                        <a:t>3.2</a:t>
+                        <a:t>36,752 characters</a:t>
                       </a:r>
                     </a:p>
                   </a:txBody>
@@ -8444,7 +8444,7 @@
                   </a:tcPr>
                 </a:tc>
               </a:tr>
-              <a:tr h="452120">
+              <a:tr h="566928">
                 <a:tc>
                   <a:txBody>
                     <a:bodyPr/>
@@ -8457,7 +8457,7 @@
                           </a:solidFill>
                           <a:latin typeface="Segoe UI"/>
                         </a:rPr>
-                        <a:t>Summarizing part 2 of 7...</a:t>
+                        <a:t>After cutting Notes, Bibliography and [12] markers</a:t>
                       </a:r>
                     </a:p>
                   </a:txBody>
@@ -8482,7 +8482,7 @@
                           </a:solidFill>
                           <a:latin typeface="Segoe UI"/>
                         </a:rPr>
-                        <a:t>7.8</a:t>
+                        <a:t>27,964 characters (8,788 cut)</a:t>
                       </a:r>
                     </a:p>
                   </a:txBody>
@@ -8496,7 +8496,7 @@
                   </a:tcPr>
                 </a:tc>
               </a:tr>
-              <a:tr h="452120">
+              <a:tr h="566928">
                 <a:tc>
                   <a:txBody>
                     <a:bodyPr/>
@@ -8509,7 +8509,7 @@
                           </a:solidFill>
                           <a:latin typeface="Segoe UI"/>
                         </a:rPr>
-                        <a:t>Summarizing part 3 of 7...</a:t>
+                        <a:t>Before: SmolLM2, whole page, 7 parts</a:t>
                       </a:r>
                     </a:p>
                   </a:txBody>
@@ -8534,7 +8534,7 @@
                           </a:solidFill>
                           <a:latin typeface="Segoe UI"/>
                         </a:rPr>
-                        <a:t>17.0</a:t>
+                        <a:t>616.4 s</a:t>
                       </a:r>
                     </a:p>
                   </a:txBody>
@@ -8548,7 +8548,7 @@
                   </a:tcPr>
                 </a:tc>
               </a:tr>
-              <a:tr h="452120">
+              <a:tr h="566928">
                 <a:tc>
                   <a:txBody>
                     <a:bodyPr/>
@@ -8561,7 +8561,7 @@
                           </a:solidFill>
                           <a:latin typeface="Segoe UI"/>
                         </a:rPr>
-                        <a:t>Summarizing part 4 of 7...</a:t>
+                        <a:t>Now: Llama 3.2 1B, opening plus first sentences, 1 part</a:t>
                       </a:r>
                     </a:p>
                   </a:txBody>
@@ -8586,7 +8586,7 @@
                           </a:solidFill>
                           <a:latin typeface="Segoe UI"/>
                         </a:rPr>
-                        <a:t>22.5</a:t>
+                        <a:t>5,968 characters read (21%), 124.6 s</a:t>
                       </a:r>
                     </a:p>
                   </a:txBody>
@@ -8600,7 +8600,7 @@
                   </a:tcPr>
                 </a:tc>
               </a:tr>
-              <a:tr h="452120">
+              <a:tr h="566928">
                 <a:tc>
                   <a:txBody>
                     <a:bodyPr/>
@@ -8613,7 +8613,7 @@
                           </a:solidFill>
                           <a:latin typeface="Segoe UI"/>
                         </a:rPr>
-                        <a:t>Summarizing part 5 of 7...</a:t>
+                        <a:t>Popup's guess for reading the whole page</a:t>
                       </a:r>
                     </a:p>
                   </a:txBody>
@@ -8638,7 +8638,7 @@
                           </a:solidFill>
                           <a:latin typeface="Segoe UI"/>
                         </a:rPr>
-                        <a:t>30.1</a:t>
+                        <a:t>about 12 minutes (692 s)</a:t>
                       </a:r>
                     </a:p>
                   </a:txBody>
@@ -8652,7 +8652,7 @@
                   </a:tcPr>
                 </a:tc>
               </a:tr>
-              <a:tr h="452120">
+              <a:tr h="566928">
                 <a:tc>
                   <a:txBody>
                     <a:bodyPr/>
@@ -8665,7 +8665,7 @@
                           </a:solidFill>
                           <a:latin typeface="Segoe UI"/>
                         </a:rPr>
-                        <a:t>Summarizing part 6 of 7...</a:t>
+                        <a:t>Same page on NVIDIA, whole page, 7 parts</a:t>
                       </a:r>
                     </a:p>
                   </a:txBody>
@@ -8690,111 +8690,7 @@
                           </a:solidFill>
                           <a:latin typeface="Segoe UI"/>
                         </a:rPr>
-                        <a:t>38.1</a:t>
-                      </a:r>
-                    </a:p>
-                  </a:txBody>
-                  <a:tcPr anchor="ctr" marL="91440" marR="91440" marT="27432" marB="27432">
-                    <a:lnB w="9525">
-                      <a:solidFill>
-                        <a:srgbClr val="D9D2C3"/>
-                      </a:solidFill>
-                    </a:lnB>
-                    <a:noFill/>
-                  </a:tcPr>
-                </a:tc>
-              </a:tr>
-              <a:tr h="452120">
-                <a:tc>
-                  <a:txBody>
-                    <a:bodyPr/>
-                    <a:lstStyle/>
-                    <a:p>
-                      <a:r>
-                        <a:rPr sz="1600" b="0">
-                          <a:solidFill>
-                            <a:srgbClr val="1C1B1A"/>
-                          </a:solidFill>
-                          <a:latin typeface="Segoe UI"/>
-                        </a:rPr>
-                        <a:t>Summarizing part 7 of 7...</a:t>
-                      </a:r>
-                    </a:p>
-                  </a:txBody>
-                  <a:tcPr anchor="ctr" marL="91440" marR="91440" marT="27432" marB="27432">
-                    <a:lnB w="9525">
-                      <a:solidFill>
-                        <a:srgbClr val="D9D2C3"/>
-                      </a:solidFill>
-                    </a:lnB>
-                    <a:noFill/>
-                  </a:tcPr>
-                </a:tc>
-                <a:tc>
-                  <a:txBody>
-                    <a:bodyPr/>
-                    <a:lstStyle/>
-                    <a:p>
-                      <a:r>
-                        <a:rPr sz="1600" b="0">
-                          <a:solidFill>
-                            <a:srgbClr val="1C1B1A"/>
-                          </a:solidFill>
-                          <a:latin typeface="Segoe UI"/>
-                        </a:rPr>
-                        <a:t>54.7</a:t>
-                      </a:r>
-                    </a:p>
-                  </a:txBody>
-                  <a:tcPr anchor="ctr" marL="91440" marR="91440" marT="27432" marB="27432">
-                    <a:lnB w="9525">
-                      <a:solidFill>
-                        <a:srgbClr val="D9D2C3"/>
-                      </a:solidFill>
-                    </a:lnB>
-                    <a:noFill/>
-                  </a:tcPr>
-                </a:tc>
-              </a:tr>
-              <a:tr h="452120">
-                <a:tc>
-                  <a:txBody>
-                    <a:bodyPr/>
-                    <a:lstStyle/>
-                    <a:p>
-                      <a:r>
-                        <a:rPr sz="1600" b="0">
-                          <a:solidFill>
-                            <a:srgbClr val="1C1B1A"/>
-                          </a:solidFill>
-                          <a:latin typeface="Segoe UI"/>
-                        </a:rPr>
-                        <a:t>Combining 7 summaries...</a:t>
-                      </a:r>
-                    </a:p>
-                  </a:txBody>
-                  <a:tcPr anchor="ctr" marL="91440" marR="91440" marT="27432" marB="27432">
-                    <a:lnB w="9525">
-                      <a:solidFill>
-                        <a:srgbClr val="D9D2C3"/>
-                      </a:solidFill>
-                    </a:lnB>
-                    <a:noFill/>
-                  </a:tcPr>
-                </a:tc>
-                <a:tc>
-                  <a:txBody>
-                    <a:bodyPr/>
-                    <a:lstStyle/>
-                    <a:p>
-                      <a:r>
-                        <a:rPr sz="1600" b="0">
-                          <a:solidFill>
-                            <a:srgbClr val="1C1B1A"/>
-                          </a:solidFill>
-                          <a:latin typeface="Segoe UI"/>
-                        </a:rPr>
-                        <a:t>60.2</a:t>
+                        <a:t>74.1 s</a:t>
                       </a:r>
                     </a:p>
                   </a:txBody>
@@ -8820,7 +8716,7 @@
         </p:nvSpPr>
         <p:spPr>
           <a:xfrm>
-            <a:off x="685800" y="5806440"/>
+            <a:off x="685800" y="5705856"/>
             <a:ext cx="10820095" cy="640080"/>
           </a:xfrm>
           <a:prstGeom prst="rect">
@@ -8842,7 +8738,7 @@
                 </a:solidFill>
                 <a:latin typeface="Segoe UI"/>
               </a:rPr>
-              <a:t>Finished at 74.1 s with the model stored. Parts up to 6,000 characters; a page over 12 parts is refused.</a:t>
+              <a:t>Built-in graphics read a part of 6,000 characters in about a minute, so the extension reads less. A button reads the whole page.</a:t>
             </a:r>
           </a:p>
         </p:txBody>
@@ -10686,7 +10582,7 @@
                           </a:solidFill>
                           <a:latin typeface="Segoe UI"/>
                         </a:rPr>
-                        <a:t>Only on two-chip laptops, if asked</a:t>
+                        <a:t>Only on two-chip laptops. Nothing to do on the client's laptop.</a:t>
                       </a:r>
                     </a:p>
                   </a:txBody>
@@ -11009,7 +10905,7 @@
                 </a:solidFill>
                 <a:latin typeface="Georgia"/>
               </a:rPr>
-              <a:t>76</a:t>
+              <a:t>93</a:t>
             </a:r>
           </a:p>
         </p:txBody>
@@ -11123,7 +11019,7 @@
                 </a:solidFill>
                 <a:latin typeface="Georgia"/>
               </a:rPr>
-              <a:t>29</a:t>
+              <a:t>31</a:t>
             </a:r>
           </a:p>
         </p:txBody>
@@ -12016,7 +11912,7 @@
         </p:nvGraphicFramePr>
         <p:xfrm>
           <a:off x="685800" y="1600200"/>
-          <a:ext cx="10820094" cy="4069080"/>
+          <a:ext cx="10820093" cy="4069080"/>
         </p:xfrm>
         <a:graphic>
           <a:graphicData uri="http://schemas.openxmlformats.org/drawingml/2006/table">
@@ -12025,11 +11921,11 @@
                 <a:tableStyleId>{2D5ABB26-0587-4C30-8999-92F81FD0307C}</a:tableStyleId>
               </a:tblPr>
               <a:tblGrid>
-                <a:gridCol w="6418700"/>
-                <a:gridCol w="1833914"/>
+                <a:gridCol w="6602091"/>
+                <a:gridCol w="1650522"/>
                 <a:gridCol w="2567480"/>
               </a:tblGrid>
-              <a:tr h="406908">
+              <a:tr h="452120">
                 <a:tc>
                   <a:txBody>
                     <a:bodyPr/>
@@ -12092,7 +11988,7 @@
                           </a:solidFill>
                           <a:latin typeface="Segoe UI"/>
                         </a:rPr>
-                        <a:t>Tokens a second</a:t>
+                        <a:t>Tokens a second (writing)</a:t>
                       </a:r>
                     </a:p>
                   </a:txBody>
@@ -12106,7 +12002,7 @@
                   </a:tcPr>
                 </a:tc>
               </a:tr>
-              <a:tr h="406908">
+              <a:tr h="452120">
                 <a:tc>
                   <a:txBody>
                     <a:bodyPr/>
@@ -12183,7 +12079,7 @@
                   </a:tcPr>
                 </a:tc>
               </a:tr>
-              <a:tr h="406908">
+              <a:tr h="452120">
                 <a:tc>
                   <a:txBody>
                     <a:bodyPr/>
@@ -12196,7 +12092,7 @@
                           </a:solidFill>
                           <a:latin typeface="Segoe UI"/>
                         </a:rPr>
-                        <a:t>Two-part article, first use (NVIDIA)</a:t>
+                        <a:t>Seven-part Lighthouse article, whole page (NVIDIA)</a:t>
                       </a:r>
                     </a:p>
                   </a:txBody>
@@ -12221,7 +12117,7 @@
                           </a:solidFill>
                           <a:latin typeface="Segoe UI"/>
                         </a:rPr>
-                        <a:t>15.9</a:t>
+                        <a:t>74.1</a:t>
                       </a:r>
                     </a:p>
                   </a:txBody>
@@ -12246,7 +12142,7 @@
                           </a:solidFill>
                           <a:latin typeface="Segoe UI"/>
                         </a:rPr>
-                        <a:t>53</a:t>
+                        <a:t>34</a:t>
                       </a:r>
                     </a:p>
                   </a:txBody>
@@ -12260,7 +12156,7 @@
                   </a:tcPr>
                 </a:tc>
               </a:tr>
-              <a:tr h="406908">
+              <a:tr h="452120">
                 <a:tc>
                   <a:txBody>
                     <a:bodyPr/>
@@ -12273,7 +12169,7 @@
                           </a:solidFill>
                           <a:latin typeface="Segoe UI"/>
                         </a:rPr>
-                        <a:t>Seven-part Lighthouse article (NVIDIA)</a:t>
+                        <a:t>Short article, offline, after label fix (NVIDIA)</a:t>
                       </a:r>
                     </a:p>
                   </a:txBody>
@@ -12298,7 +12194,7 @@
                           </a:solidFill>
                           <a:latin typeface="Segoe UI"/>
                         </a:rPr>
-                        <a:t>74.1</a:t>
+                        <a:t>17.7</a:t>
                       </a:r>
                     </a:p>
                   </a:txBody>
@@ -12323,7 +12219,7 @@
                           </a:solidFill>
                           <a:latin typeface="Segoe UI"/>
                         </a:rPr>
-                        <a:t>34</a:t>
+                        <a:t>65</a:t>
                       </a:r>
                     </a:p>
                   </a:txBody>
@@ -12337,7 +12233,7 @@
                   </a:tcPr>
                 </a:tc>
               </a:tr>
-              <a:tr h="406908">
+              <a:tr h="452120">
                 <a:tc>
                   <a:txBody>
                     <a:bodyPr/>
@@ -12350,7 +12246,7 @@
                           </a:solidFill>
                           <a:latin typeface="Segoe UI"/>
                         </a:rPr>
-                        <a:t>Short article, offline, before label fix</a:t>
+                        <a:t>Lighthouse, whole page, SmolLM2 (Intel, before the speed work)</a:t>
                       </a:r>
                     </a:p>
                   </a:txBody>
@@ -12375,7 +12271,7 @@
                           </a:solidFill>
                           <a:latin typeface="Segoe UI"/>
                         </a:rPr>
-                        <a:t>15.3</a:t>
+                        <a:t>616.4</a:t>
                       </a:r>
                     </a:p>
                   </a:txBody>
@@ -12400,7 +12296,7 @@
                           </a:solidFill>
                           <a:latin typeface="Segoe UI"/>
                         </a:rPr>
-                        <a:t>40</a:t>
+                        <a:t>4</a:t>
                       </a:r>
                     </a:p>
                   </a:txBody>
@@ -12414,7 +12310,7 @@
                   </a:tcPr>
                 </a:tc>
               </a:tr>
-              <a:tr h="406908">
+              <a:tr h="452120">
                 <a:tc>
                   <a:txBody>
                     <a:bodyPr/>
@@ -12427,7 +12323,7 @@
                           </a:solidFill>
                           <a:latin typeface="Segoe UI"/>
                         </a:rPr>
-                        <a:t>Two-part article, offline, before label fix</a:t>
+                        <a:t>Short article, first use, Llama 3.2 1B (Intel, now)</a:t>
                       </a:r>
                     </a:p>
                   </a:txBody>
@@ -12452,7 +12348,7 @@
                           </a:solidFill>
                           <a:latin typeface="Segoe UI"/>
                         </a:rPr>
-                        <a:t>16.5</a:t>
+                        <a:t>200.6</a:t>
                       </a:r>
                     </a:p>
                   </a:txBody>
@@ -12477,7 +12373,7 @@
                           </a:solidFill>
                           <a:latin typeface="Segoe UI"/>
                         </a:rPr>
-                        <a:t>42</a:t>
+                        <a:t>2</a:t>
                       </a:r>
                     </a:p>
                   </a:txBody>
@@ -12491,7 +12387,7 @@
                   </a:tcPr>
                 </a:tc>
               </a:tr>
-              <a:tr h="406908">
+              <a:tr h="452120">
                 <a:tc>
                   <a:txBody>
                     <a:bodyPr/>
@@ -12504,7 +12400,7 @@
                           </a:solidFill>
                           <a:latin typeface="Segoe UI"/>
                         </a:rPr>
-                        <a:t>Short article, offline, after label fix</a:t>
+                        <a:t>Lighthouse, shortened to 21%, Llama 3.2 1B (Intel, now)</a:t>
                       </a:r>
                     </a:p>
                   </a:txBody>
@@ -12529,7 +12425,7 @@
                           </a:solidFill>
                           <a:latin typeface="Segoe UI"/>
                         </a:rPr>
-                        <a:t>17.7</a:t>
+                        <a:t>124.6</a:t>
                       </a:r>
                     </a:p>
                   </a:txBody>
@@ -12554,7 +12450,7 @@
                           </a:solidFill>
                           <a:latin typeface="Segoe UI"/>
                         </a:rPr>
-                        <a:t>65</a:t>
+                        <a:t>1.8</a:t>
                       </a:r>
                     </a:p>
                   </a:txBody>
@@ -12568,7 +12464,7 @@
                   </a:tcPr>
                 </a:tc>
               </a:tr>
-              <a:tr h="406908">
+              <a:tr h="452120">
                 <a:tc>
                   <a:txBody>
                     <a:bodyPr/>
@@ -12581,7 +12477,7 @@
                           </a:solidFill>
                           <a:latin typeface="Segoe UI"/>
                         </a:rPr>
-                        <a:t>Two-part article, offline, after label fix</a:t>
+                        <a:t>Long fixture article, shortened to 50% (Intel, now)</a:t>
                       </a:r>
                     </a:p>
                   </a:txBody>
@@ -12606,7 +12502,7 @@
                           </a:solidFill>
                           <a:latin typeface="Segoe UI"/>
                         </a:rPr>
-                        <a:t>16.0</a:t>
+                        <a:t>103.8</a:t>
                       </a:r>
                     </a:p>
                   </a:txBody>
@@ -12631,7 +12527,7 @@
                           </a:solidFill>
                           <a:latin typeface="Segoe UI"/>
                         </a:rPr>
-                        <a:t>45</a:t>
+                        <a:t>1.9</a:t>
                       </a:r>
                     </a:p>
                   </a:txBody>
@@ -12645,7 +12541,7 @@
                   </a:tcPr>
                 </a:tc>
               </a:tr>
-              <a:tr h="406908">
+              <a:tr h="452120">
                 <a:tc>
                   <a:txBody>
                     <a:bodyPr/>
@@ -12658,7 +12554,7 @@
                           </a:solidFill>
                           <a:latin typeface="Segoe UI"/>
                         </a:rPr>
-                        <a:t>Short article, Intel, SmolLM2 360M, first use</a:t>
+                        <a:t>Lighthouse, Fast quality, SmolLM2 (Intel; the summary failed)</a:t>
                       </a:r>
                     </a:p>
                   </a:txBody>
@@ -12683,7 +12579,7 @@
                           </a:solidFill>
                           <a:latin typeface="Segoe UI"/>
                         </a:rPr>
-                        <a:t>199.2</a:t>
+                        <a:t>64.7</a:t>
                       </a:r>
                     </a:p>
                   </a:txBody>
@@ -12709,83 +12605,6 @@
                           <a:latin typeface="Segoe UI"/>
                         </a:rPr>
                         <a:t>4</a:t>
-                      </a:r>
-                    </a:p>
-                  </a:txBody>
-                  <a:tcPr anchor="ctr" marL="91440" marR="91440" marT="27432" marB="27432">
-                    <a:lnB w="9525">
-                      <a:solidFill>
-                        <a:srgbClr val="D9D2C3"/>
-                      </a:solidFill>
-                    </a:lnB>
-                    <a:noFill/>
-                  </a:tcPr>
-                </a:tc>
-              </a:tr>
-              <a:tr h="406908">
-                <a:tc>
-                  <a:txBody>
-                    <a:bodyPr/>
-                    <a:lstStyle/>
-                    <a:p>
-                      <a:r>
-                        <a:rPr sz="1600" b="0">
-                          <a:solidFill>
-                            <a:srgbClr val="1C1B1A"/>
-                          </a:solidFill>
-                          <a:latin typeface="Segoe UI"/>
-                        </a:rPr>
-                        <a:t>Two-part article, Intel, SmolLM2 360M</a:t>
-                      </a:r>
-                    </a:p>
-                  </a:txBody>
-                  <a:tcPr anchor="ctr" marL="91440" marR="91440" marT="27432" marB="27432">
-                    <a:lnB w="9525">
-                      <a:solidFill>
-                        <a:srgbClr val="D9D2C3"/>
-                      </a:solidFill>
-                    </a:lnB>
-                    <a:noFill/>
-                  </a:tcPr>
-                </a:tc>
-                <a:tc>
-                  <a:txBody>
-                    <a:bodyPr/>
-                    <a:lstStyle/>
-                    <a:p>
-                      <a:r>
-                        <a:rPr sz="1600" b="0">
-                          <a:solidFill>
-                            <a:srgbClr val="1C1B1A"/>
-                          </a:solidFill>
-                          <a:latin typeface="Segoe UI"/>
-                        </a:rPr>
-                        <a:t>149.1</a:t>
-                      </a:r>
-                    </a:p>
-                  </a:txBody>
-                  <a:tcPr anchor="ctr" marL="91440" marR="91440" marT="27432" marB="27432">
-                    <a:lnB w="9525">
-                      <a:solidFill>
-                        <a:srgbClr val="D9D2C3"/>
-                      </a:solidFill>
-                    </a:lnB>
-                    <a:noFill/>
-                  </a:tcPr>
-                </a:tc>
-                <a:tc>
-                  <a:txBody>
-                    <a:bodyPr/>
-                    <a:lstStyle/>
-                    <a:p>
-                      <a:r>
-                        <a:rPr sz="1600" b="0">
-                          <a:solidFill>
-                            <a:srgbClr val="1C1B1A"/>
-                          </a:solidFill>
-                          <a:latin typeface="Segoe UI"/>
-                        </a:rPr>
-                        <a:t>5</a:t>
                       </a:r>
                     </a:p>
                   </a:txBody>
@@ -12833,7 +12652,7 @@
                 </a:solidFill>
                 <a:latin typeface="Segoe UI"/>
               </a:rPr>
-              <a:t>Disturbed runs (other programs running) are excluded: first use 207 s, Lighthouse 101.6 s, short 13.4 s, two-part 32.2 s.</a:t>
+              <a:t>All from a hidden test browser on the developer laptop. Not yet measured on the client's laptop. Disturbed runs are left out.</a:t>
             </a:r>
           </a:p>
         </p:txBody>
@@ -13044,7 +12863,7 @@
         </p:nvGraphicFramePr>
         <p:xfrm>
           <a:off x="685800" y="1600200"/>
-          <a:ext cx="10820094" cy="3401568"/>
+          <a:ext cx="10820094" cy="3968496"/>
         </p:xfrm>
         <a:graphic>
           <a:graphicData uri="http://schemas.openxmlformats.org/drawingml/2006/table">
@@ -13146,7 +12965,7 @@
                           </a:solidFill>
                           <a:latin typeface="Segoe UI"/>
                         </a:rPr>
-                        <a:t>Forced the high-performance card in the test setup, added a warm-up step, and an automatic smaller model with a note on Intel.</a:t>
+                        <a:t>A warm-up step and an on-screen note on Intel. The speed work in the last row later replaced the automatic smaller model.</a:t>
                       </a:r>
                     </a:p>
                   </a:txBody>
@@ -13355,6 +13174,58 @@
                           <a:latin typeface="Segoe UI"/>
                         </a:rPr>
                         <a:t>A part too long for the model is cut in half and retried. The answer limit is 10 minutes. The popup now shows a technical detail line.</a:t>
+                      </a:r>
+                    </a:p>
+                  </a:txBody>
+                  <a:tcPr anchor="ctr" marL="91440" marR="91440" marT="27432" marB="27432">
+                    <a:lnB w="9525">
+                      <a:solidFill>
+                        <a:srgbClr val="D9D2C3"/>
+                      </a:solidFill>
+                    </a:lnB>
+                    <a:noFill/>
+                  </a:tcPr>
+                </a:tc>
+              </a:tr>
+              <a:tr h="566928">
+                <a:tc>
+                  <a:txBody>
+                    <a:bodyPr/>
+                    <a:lstStyle/>
+                    <a:p>
+                      <a:r>
+                        <a:rPr sz="1600" b="0">
+                          <a:solidFill>
+                            <a:srgbClr val="1C1B1A"/>
+                          </a:solidFill>
+                          <a:latin typeface="Segoe UI"/>
+                        </a:rPr>
+                        <a:t>Ten minutes for a long page on built-in graphics (the client's chip)</a:t>
+                      </a:r>
+                    </a:p>
+                  </a:txBody>
+                  <a:tcPr anchor="ctr" marL="91440" marR="91440" marT="27432" marB="27432">
+                    <a:lnB w="9525">
+                      <a:solidFill>
+                        <a:srgbClr val="D9D2C3"/>
+                      </a:solidFill>
+                    </a:lnB>
+                    <a:noFill/>
+                  </a:tcPr>
+                </a:tc>
+                <a:tc>
+                  <a:txBody>
+                    <a:bodyPr/>
+                    <a:lstStyle/>
+                    <a:p>
+                      <a:r>
+                        <a:rPr sz="1600" b="0">
+                          <a:solidFill>
+                            <a:srgbClr val="1C1B1A"/>
+                          </a:solidFill>
+                          <a:latin typeface="Segoe UI"/>
+                        </a:rPr>
+                        <a:t>Measured: reading is the cost. Read less of a long page, keep the accurate model: 616 s down to 125 s.</a:t>
                       </a:r>
                     </a:p>
                   </a:txBody>
@@ -13380,7 +13251,7 @@
         </p:nvSpPr>
         <p:spPr>
           <a:xfrm>
-            <a:off x="685800" y="5138928"/>
+            <a:off x="685800" y="5705856"/>
             <a:ext cx="10820095" cy="640080"/>
           </a:xfrm>
           <a:prstGeom prst="rect">
@@ -13402,7 +13273,7 @@
                 </a:solidFill>
                 <a:latin typeface="Segoe UI"/>
               </a:rPr>
-              <a:t>Found and fixed on 21 and 24 October 2026. Each one is written in the development log.</a:t>
+              <a:t>Found and fixed on 21, 24 and 26 October 2026. Each one is written in the development log.</a:t>
             </a:r>
           </a:p>
         </p:txBody>
@@ -13645,7 +13516,7 @@
                 </a:solidFill>
                 <a:latin typeface="Segoe UI"/>
               </a:rPr>
-              <a:t>Client's laptop: not tested yet. Chip, memory and free disk are unknown.</a:t>
+              <a:t>Client's laptop: details known (Iris Xe, 16 GB, Chrome 156), but never run there.</a:t>
             </a:r>
           </a:p>
           <a:p>
@@ -13669,7 +13540,7 @@
                 </a:solidFill>
                 <a:latin typeface="Segoe UI"/>
               </a:rPr>
-              <a:t>setup.bat --gpu: tested only on a test registry key, not on real Chrome.</a:t>
+              <a:t>Speed numbers are from a hidden browser on the developer laptop; a visible window may differ.</a:t>
             </a:r>
           </a:p>
           <a:p>
@@ -13693,7 +13564,7 @@
                 </a:solidFill>
                 <a:latin typeface="Segoe UI"/>
               </a:rPr>
-              <a:t>Visible Chrome: one real page on 24 October, no full click-through yet.</a:t>
+              <a:t>setup.bat --gpu: tested only on a test registry key; not needed on the client's laptop.</a:t>
             </a:r>
           </a:p>
           <a:p>
@@ -13717,7 +13588,7 @@
                 </a:solidFill>
                 <a:latin typeface="Segoe UI"/>
               </a:rPr>
-              <a:t>English only. Other languages were not tried.</a:t>
+              <a:t>A shortened summary covers about a fifth of a long page; the whole page takes 5 to 12 minutes.</a:t>
             </a:r>
           </a:p>
           <a:p>
@@ -13741,7 +13612,7 @@
                 </a:solidFill>
                 <a:latin typeface="Segoe UI"/>
               </a:rPr>
-              <a:t>Small-model slips. A 7-part page takes about 10 minutes on the Intel chip.</a:t>
+              <a:t>English only. Small-model slips. Another engine (Transformers.js) was not tried.</a:t>
             </a:r>
           </a:p>
           <a:p>
@@ -14032,7 +13903,7 @@
                 </a:solidFill>
                 <a:latin typeface="Segoe UI"/>
               </a:rPr>
-              <a:t>Summarize the Lighthouse article with the model stored: 74.1 s in seven parts (clean run).</a:t>
+              <a:t>Open the Lighthouse article, summarize: about 2 minutes on built-in graphics (124.6 s measured), with the shortened-page notice.</a:t>
             </a:r>
           </a:p>
           <a:p>
@@ -14080,7 +13951,7 @@
                 </a:solidFill>
                 <a:latin typeface="Segoe UI"/>
               </a:rPr>
-              <a:t>Turn off Wi-Fi and summarize a short article. Say which run: 17.7 s after the label fix, or 15.3 s before it.</a:t>
+              <a:t>Turn off Wi-Fi and summarize a short article. Say which run: 17.7 s after the label fix, 15.3 s before it.</a:t>
             </a:r>
           </a:p>
           <a:p>
@@ -14128,7 +13999,7 @@
                 </a:solidFill>
                 <a:latin typeface="Segoe UI"/>
               </a:rPr>
-              <a:t>Do not show the first download live: it took 158.3 s. Label any screenshot from a disturbed run.</a:t>
+              <a:t>Do not show the first download live: it takes minutes. Do not press Read the whole page in front of an audience.</a:t>
             </a:r>
           </a:p>
         </p:txBody>
@@ -14982,7 +14853,7 @@
                           </a:solidFill>
                           <a:latin typeface="Segoe UI"/>
                         </a:rPr>
-                        <a:t>Llama 3.2 1B on the graphics card (SmolLM2 360M on Intel)</a:t>
+                        <a:t>Llama 3.2 1B on this laptop's graphics (SmolLM2 360M as a Fast choice)</a:t>
                       </a:r>
                     </a:p>
                   </a:txBody>
@@ -15367,7 +15238,7 @@
                           </a:solidFill>
                           <a:latin typeface="Segoe UI"/>
                         </a:rPr>
-                        <a:t>15.3 s to 17.7 s for a short article, model stored</a:t>
+                        <a:t>A long page in about 2 minutes on built-in Intel graphics (124.6 s measured); a short page in 15 to 18 s on NVIDIA</a:t>
                       </a:r>
                     </a:p>
                   </a:txBody>

</xml_diff>

<commit_message>
docs(v2): visible-window timing on the developer laptop (118.7, 101.7, 116.7 s for the Lighthouse page), recorded in D7, DEVLOG, README, report, KT and deck; plan intel-visible
Co-Authored-By: Claude Sonnet 5.5 <noreply@anthropic.com>
</commit_message>
<xml_diff>
--- a/finalsem/docs/ppt/FinalSem_Deck.pptx
+++ b/finalsem/docs/ppt/FinalSem_Deck.pptx
@@ -1365,7 +1365,7 @@
           <a:lstStyle/>
           <a:p>
             <a:r>
-              <a:t>These are the clean runs. The first three rows are the NVIDIA card. The fourth row is the old Intel result, before the speed work: ten minutes for the Lighthouse page. The next three rows are the Intel chip with the new defaults: the accurate main model, long pages shortened, and short answers. The Lighthouse page now takes about two minutes. The last row is the Fast setting. It is quicker, but its Lighthouse summary only repeated the prompt, which is why Fast is not the default. None of these numbers comes from the client's laptop. I expect about two minutes there, and I will measure it.</a:t>
+              <a:t>These are the clean runs. The first three rows are the NVIDIA card. The fourth row is the old Intel result, before the speed work: ten minutes for the Lighthouse page. The next three rows are the Intel chip with the new defaults: the accurate main model, long pages shortened, and short answers. The Lighthouse page now takes about two minutes. The last row is the Fast setting. It is quicker, but its Lighthouse summary only repeated the prompt, which is why Fast is not the default. None of these numbers comes from the client's laptop. I expect about two minutes there, and I will measure it. I also timed the Lighthouse page three times in a row in a visible Chrome window on mains power: 118.7, 101.7 and 116.7 seconds, a little quicker than the hidden browser's 124.6 seconds, with no slowdown across the three runs. So the hidden test browser is not what makes reading slow; the chip is.</a:t>
             </a:r>
           </a:p>
         </p:txBody>
@@ -1505,7 +1505,7 @@
           <a:lstStyle/>
           <a:p>
             <a:r>
-              <a:t>Some things are not finished, and I want to be exact about them. The client's laptop details are known, but I have not run the extension on it, so its real speed is not measured. All my speed numbers come from a hidden test browser on the developer laptop, and a visible window might be faster or slower. A shortened summary rests on about a fifth of a long page, and reading the whole page takes five to twelve minutes on this kind of chip. The model is small and made for English. I did not try a different engine, because a stronger model advised me to measure in a visible window first. Cutting a too-long part in half is covered by unit tests and the pretend model, because no real part overflowed the window.</a:t>
+              <a:t>Some things are not finished, and I want to be exact about them. The client's laptop details are known, but I have not run the extension on it, so its real speed is not measured. Most of my speed numbers come from a hidden test browser on the developer laptop. I also timed a visible window, three runs in a row, and it was about ten percent quicker, but nothing was timed on the client's laptop. A shortened summary rests on about a fifth of a long page, and reading the whole page takes five to twelve minutes on this kind of chip. The model is small and made for English. I did not try a different engine, because a stronger model advised me to measure in a visible window first. Cutting a too-long part in half is covered by unit tests and the pretend model, because no real part overflowed the window.</a:t>
             </a:r>
           </a:p>
         </p:txBody>
@@ -11921,9 +11921,9 @@
                 <a:tableStyleId>{2D5ABB26-0587-4C30-8999-92F81FD0307C}</a:tableStyleId>
               </a:tblPr>
               <a:tblGrid>
-                <a:gridCol w="6602091"/>
-                <a:gridCol w="1650522"/>
-                <a:gridCol w="2567480"/>
+                <a:gridCol w="6051917"/>
+                <a:gridCol w="2384088"/>
+                <a:gridCol w="2384088"/>
               </a:tblGrid>
               <a:tr h="452120">
                 <a:tc>
@@ -12169,7 +12169,7 @@
                           </a:solidFill>
                           <a:latin typeface="Segoe UI"/>
                         </a:rPr>
-                        <a:t>Short article, offline, after label fix (NVIDIA)</a:t>
+                        <a:t>Lighthouse, whole page, SmolLM2 (Intel, before the speed work)</a:t>
                       </a:r>
                     </a:p>
                   </a:txBody>
@@ -12194,7 +12194,7 @@
                           </a:solidFill>
                           <a:latin typeface="Segoe UI"/>
                         </a:rPr>
-                        <a:t>17.7</a:t>
+                        <a:t>616.4</a:t>
                       </a:r>
                     </a:p>
                   </a:txBody>
@@ -12219,7 +12219,7 @@
                           </a:solidFill>
                           <a:latin typeface="Segoe UI"/>
                         </a:rPr>
-                        <a:t>65</a:t>
+                        <a:t>4</a:t>
                       </a:r>
                     </a:p>
                   </a:txBody>
@@ -12246,7 +12246,7 @@
                           </a:solidFill>
                           <a:latin typeface="Segoe UI"/>
                         </a:rPr>
-                        <a:t>Lighthouse, whole page, SmolLM2 (Intel, before the speed work)</a:t>
+                        <a:t>Short article, first use, Llama 3.2 1B (Intel, now)</a:t>
                       </a:r>
                     </a:p>
                   </a:txBody>
@@ -12271,7 +12271,7 @@
                           </a:solidFill>
                           <a:latin typeface="Segoe UI"/>
                         </a:rPr>
-                        <a:t>616.4</a:t>
+                        <a:t>200.6</a:t>
                       </a:r>
                     </a:p>
                   </a:txBody>
@@ -12296,7 +12296,7 @@
                           </a:solidFill>
                           <a:latin typeface="Segoe UI"/>
                         </a:rPr>
-                        <a:t>4</a:t>
+                        <a:t>2</a:t>
                       </a:r>
                     </a:p>
                   </a:txBody>
@@ -12323,7 +12323,7 @@
                           </a:solidFill>
                           <a:latin typeface="Segoe UI"/>
                         </a:rPr>
-                        <a:t>Short article, first use, Llama 3.2 1B (Intel, now)</a:t>
+                        <a:t>Lighthouse, shortened to 21%, Llama 3.2 1B (Intel, now)</a:t>
                       </a:r>
                     </a:p>
                   </a:txBody>
@@ -12348,7 +12348,7 @@
                           </a:solidFill>
                           <a:latin typeface="Segoe UI"/>
                         </a:rPr>
-                        <a:t>200.6</a:t>
+                        <a:t>124.6</a:t>
                       </a:r>
                     </a:p>
                   </a:txBody>
@@ -12373,7 +12373,7 @@
                           </a:solidFill>
                           <a:latin typeface="Segoe UI"/>
                         </a:rPr>
-                        <a:t>2</a:t>
+                        <a:t>1.8</a:t>
                       </a:r>
                     </a:p>
                   </a:txBody>
@@ -12400,7 +12400,7 @@
                           </a:solidFill>
                           <a:latin typeface="Segoe UI"/>
                         </a:rPr>
-                        <a:t>Lighthouse, shortened to 21%, Llama 3.2 1B (Intel, now)</a:t>
+                        <a:t>Long fixture article, shortened to 50% (Intel, now)</a:t>
                       </a:r>
                     </a:p>
                   </a:txBody>
@@ -12425,7 +12425,7 @@
                           </a:solidFill>
                           <a:latin typeface="Segoe UI"/>
                         </a:rPr>
-                        <a:t>124.6</a:t>
+                        <a:t>103.8</a:t>
                       </a:r>
                     </a:p>
                   </a:txBody>
@@ -12450,7 +12450,7 @@
                           </a:solidFill>
                           <a:latin typeface="Segoe UI"/>
                         </a:rPr>
-                        <a:t>1.8</a:t>
+                        <a:t>1.9</a:t>
                       </a:r>
                     </a:p>
                   </a:txBody>
@@ -12477,7 +12477,7 @@
                           </a:solidFill>
                           <a:latin typeface="Segoe UI"/>
                         </a:rPr>
-                        <a:t>Long fixture article, shortened to 50% (Intel, now)</a:t>
+                        <a:t>Lighthouse, shortened, visible window, 3 runs (Intel, now)</a:t>
                       </a:r>
                     </a:p>
                   </a:txBody>
@@ -12502,7 +12502,7 @@
                           </a:solidFill>
                           <a:latin typeface="Segoe UI"/>
                         </a:rPr>
-                        <a:t>103.8</a:t>
+                        <a:t>118.7 / 101.7 / 116.7</a:t>
                       </a:r>
                     </a:p>
                   </a:txBody>
@@ -12527,7 +12527,7 @@
                           </a:solidFill>
                           <a:latin typeface="Segoe UI"/>
                         </a:rPr>
-                        <a:t>1.9</a:t>
+                        <a:t>2.0</a:t>
                       </a:r>
                     </a:p>
                   </a:txBody>
@@ -12652,7 +12652,7 @@
                 </a:solidFill>
                 <a:latin typeface="Segoe UI"/>
               </a:rPr>
-              <a:t>All from a hidden test browser on the developer laptop. Not yet measured on the client's laptop. Disturbed runs are left out.</a:t>
+              <a:t>Developer laptop. Hidden test browser, except the visible-window row. Not yet measured on the client's laptop.</a:t>
             </a:r>
           </a:p>
         </p:txBody>
@@ -13540,7 +13540,7 @@
                 </a:solidFill>
                 <a:latin typeface="Segoe UI"/>
               </a:rPr>
-              <a:t>Speed numbers are from a hidden browser on the developer laptop; a visible window may differ.</a:t>
+              <a:t>Visible window checked on the developer laptop (118.7, 101.7, 116.7 s); not on the client's.</a:t>
             </a:r>
           </a:p>
           <a:p>

</xml_diff>